<commit_message>
Türkçe afet tweet sınıflandırma — QLoRA benchmark review
</commit_message>
<xml_diff>
--- a/report/SunumFinal_Mustafa_Kirpik.pptx
+++ b/report/SunumFinal_Mustafa_Kirpik.pptx
@@ -743,6 +743,101 @@
             </c:numRef>
           </c:val>
         </c:ser>
+        <c:ser>
+          <c:idx val="3"/>
+          <c:order val="3"/>
+          <c:tx>
+            <c:strRef>
+              <c:f>Sheet1!$E$1</c:f>
+              <c:strCache>
+                <c:ptCount val="1"/>
+                <c:pt idx="0">
+                  <c:v>Gemma-4-E2B</c:v>
+                </c:pt>
+              </c:strCache>
+            </c:strRef>
+          </c:tx>
+          <c:spPr>
+            <a:solidFill>
+              <a:srgbClr val="C96A28"/>
+            </a:solidFill>
+            <a:effectLst/>
+          </c:spPr>
+          <c:invertIfNegative val="0"/>
+          <c:dLbls>
+            <c:numFmt formatCode="#,##0" sourceLinked="0"/>
+            <c:txPr>
+              <a:bodyPr/>
+              <a:lstStyle/>
+              <a:p>
+                <a:pPr>
+                  <a:defRPr b="0" i="0" strike="noStrike" sz="1200" u="none">
+                    <a:solidFill>
+                      <a:srgbClr val="000000"/>
+                    </a:solidFill>
+                    <a:latin typeface="Arial"/>
+                  </a:defRPr>
+                </a:pPr>
+              </a:p>
+            </c:txPr>
+            <c:showLegendKey val="0"/>
+            <c:showVal val="0"/>
+            <c:showCatName val="0"/>
+            <c:showSerName val="0"/>
+            <c:showPercent val="0"/>
+            <c:showBubbleSize val="0"/>
+            <c:showLeaderLines val="0"/>
+          </c:dLbls>
+          <c:cat>
+            <c:multiLvlStrRef>
+              <c:f>Sheet1!$A$2:$A$6</c:f>
+              <c:multiLvlStrCache>
+                <c:ptCount val="5"/>
+                <c:lvl>
+                  <c:pt idx="0">
+                    <c:v>Yardım</c:v>
+                  </c:pt>
+                  <c:pt idx="1">
+                    <c:v>Kayıp</c:v>
+                  </c:pt>
+                  <c:pt idx="2">
+                    <c:v>Altyapı</c:v>
+                  </c:pt>
+                  <c:pt idx="3">
+                    <c:v>Bağış</c:v>
+                  </c:pt>
+                  <c:pt idx="4">
+                    <c:v>Diğer</c:v>
+                  </c:pt>
+                </c:lvl>
+              </c:multiLvlStrCache>
+            </c:multiLvlStrRef>
+          </c:cat>
+          <c:val>
+            <c:numRef>
+              <c:f>Sheet1!$E$2:$E$6</c:f>
+              <c:numCache>
+                <c:formatCode>General</c:formatCode>
+                <c:ptCount val="5"/>
+                <c:pt idx="0">
+                  <c:v>0.86</c:v>
+                </c:pt>
+                <c:pt idx="1">
+                  <c:v>0.46</c:v>
+                </c:pt>
+                <c:pt idx="2">
+                  <c:v>0.91</c:v>
+                </c:pt>
+                <c:pt idx="3">
+                  <c:v>0.76</c:v>
+                </c:pt>
+                <c:pt idx="4">
+                  <c:v>0.71</c:v>
+                </c:pt>
+              </c:numCache>
+            </c:numRef>
+          </c:val>
+        </c:ser>
         <c:dLbls>
           <c:numFmt formatCode="#,##0" sourceLinked="0"/>
           <c:txPr>
@@ -882,7 +977,7 @@
         <a:lstStyle/>
         <a:p>
           <a:pPr>
-            <a:defRPr sz="1200">
+            <a:defRPr sz="1100">
               <a:solidFill>
                 <a:srgbClr val="1B2733"/>
               </a:solidFill>
@@ -953,7 +1048,7 @@
               <a:lstStyle/>
               <a:p>
                 <a:pPr>
-                  <a:defRPr b="0" i="0" strike="noStrike" sz="1400" u="none">
+                  <a:defRPr b="0" i="0" strike="noStrike" sz="1300" u="none">
                     <a:solidFill>
                       <a:srgbClr val="0F2741"/>
                     </a:solidFill>
@@ -990,9 +1085,9 @@
           </c:marker>
           <c:cat>
             <c:multiLvlStrRef>
-              <c:f>Sheet1!$A$2:$A$4</c:f>
+              <c:f>Sheet1!$A$2:$A$5</c:f>
               <c:multiLvlStrCache>
-                <c:ptCount val="3"/>
+                <c:ptCount val="4"/>
                 <c:lvl>
                   <c:pt idx="0">
                     <c:v>360M
@@ -1006,16 +1101,20 @@
                     <c:v>1.5B
 Qwen2.5</c:v>
                   </c:pt>
+                  <c:pt idx="3">
+                    <c:v>5B
+Gemma-4</c:v>
+                  </c:pt>
                 </c:lvl>
               </c:multiLvlStrCache>
             </c:multiLvlStrRef>
           </c:cat>
           <c:val>
             <c:numRef>
-              <c:f>Sheet1!$B$2:$B$4</c:f>
+              <c:f>Sheet1!$B$2:$B$5</c:f>
               <c:numCache>
                 <c:formatCode>General</c:formatCode>
-                <c:ptCount val="3"/>
+                <c:ptCount val="4"/>
                 <c:pt idx="0">
                   <c:v>0.588</c:v>
                 </c:pt>
@@ -1024,6 +1123,9 @@
                 </c:pt>
                 <c:pt idx="2">
                   <c:v>0.914</c:v>
+                </c:pt>
+                <c:pt idx="3">
+                  <c:v>0.74</c:v>
                 </c:pt>
               </c:numCache>
             </c:numRef>
@@ -1037,7 +1139,7 @@
             <a:lstStyle/>
             <a:p>
               <a:pPr>
-                <a:defRPr b="0" i="0" strike="noStrike" sz="1400" u="none">
+                <a:defRPr b="0" i="0" strike="noStrike" sz="1300" u="none">
                   <a:solidFill>
                     <a:srgbClr val="0F2741"/>
                   </a:solidFill>
@@ -1085,7 +1187,7 @@
           <a:lstStyle/>
           <a:p>
             <a:pPr>
-              <a:defRPr sz="1200" b="0" i="0" u="none" strike="noStrike">
+              <a:defRPr sz="1100" b="0" i="0" u="none" strike="noStrike">
                 <a:solidFill>
                   <a:srgbClr val="1B2733"/>
                 </a:solidFill>
@@ -4804,7 +4906,7 @@
                 <a:ea typeface="Calibri" pitchFamily="34" charset="-122"/>
                 <a:cs typeface="Calibri" pitchFamily="34" charset="-120"/>
               </a:rPr>
-              <a:t>Gemma-4 donanım kısıtıyla ertelendi (eklenecek).</a:t>
+              <a:t>Gemma-4 için modele özel hiperparametre araması yapılmadı (ortak reçete).</a:t>
             </a:r>
             <a:endParaRPr lang="en-US" sz="1300" dirty="0"/>
           </a:p>
@@ -5311,7 +5413,7 @@
               <a:buNone/>
             </a:pPr>
             <a:r>
-              <a:rPr lang="en-US" sz="1900" b="1" dirty="0">
+              <a:rPr lang="en-US" sz="1700" b="1" dirty="0">
                 <a:solidFill>
                   <a:srgbClr val="E8833A"/>
                 </a:solidFill>
@@ -5321,7 +5423,7 @@
               </a:rPr>
               <a:t>0.094 → 0.914</a:t>
             </a:r>
-            <a:endParaRPr lang="en-US" sz="1900" dirty="0"/>
+            <a:endParaRPr lang="en-US" sz="1700" dirty="0"/>
           </a:p>
         </p:txBody>
       </p:sp>
@@ -5350,7 +5452,7 @@
               <a:buNone/>
             </a:pPr>
             <a:r>
-              <a:rPr lang="en-US" sz="1200" dirty="0">
+              <a:rPr lang="en-US" sz="1150" dirty="0">
                 <a:solidFill>
                   <a:srgbClr val="D5E0EA"/>
                 </a:solidFill>
@@ -5360,7 +5462,7 @@
               </a:rPr>
               <a:t>Zero-shot çöküyor, QLoRA çözüyor (Macro-F1)</a:t>
             </a:r>
-            <a:endParaRPr lang="en-US" sz="1200" dirty="0"/>
+            <a:endParaRPr lang="en-US" sz="1150" dirty="0"/>
           </a:p>
         </p:txBody>
       </p:sp>
@@ -5411,7 +5513,7 @@
               <a:buNone/>
             </a:pPr>
             <a:r>
-              <a:rPr lang="en-US" sz="1900" b="1" dirty="0">
+              <a:rPr lang="en-US" sz="1700" b="1" dirty="0">
                 <a:solidFill>
                   <a:srgbClr val="E8833A"/>
                 </a:solidFill>
@@ -5419,9 +5521,9 @@
                 <a:ea typeface="Calibri" pitchFamily="34" charset="-122"/>
                 <a:cs typeface="Calibri" pitchFamily="34" charset="-120"/>
               </a:rPr>
-              <a:t>3 model</a:t>
+              <a:t>4 model</a:t>
             </a:r>
-            <a:endParaRPr lang="en-US" sz="1900" dirty="0"/>
+            <a:endParaRPr lang="en-US" sz="1700" dirty="0"/>
           </a:p>
         </p:txBody>
       </p:sp>
@@ -5450,7 +5552,7 @@
               <a:buNone/>
             </a:pPr>
             <a:r>
-              <a:rPr lang="en-US" sz="1200" dirty="0">
+              <a:rPr lang="en-US" sz="1150" dirty="0">
                 <a:solidFill>
                   <a:srgbClr val="D5E0EA"/>
                 </a:solidFill>
@@ -5458,9 +5560,9 @@
                 <a:ea typeface="Calibri" pitchFamily="34" charset="-122"/>
                 <a:cs typeface="Calibri" pitchFamily="34" charset="-120"/>
               </a:rPr>
-              <a:t>SmolLM2 · TinyLlama · Qwen2.5 — şart karşılandı</a:t>
+              <a:t>SmolLM2 · TinyLlama · Qwen2.5 · Gemma-4</a:t>
             </a:r>
-            <a:endParaRPr lang="en-US" sz="1200" dirty="0"/>
+            <a:endParaRPr lang="en-US" sz="1150" dirty="0"/>
           </a:p>
         </p:txBody>
       </p:sp>
@@ -5511,7 +5613,7 @@
               <a:buNone/>
             </a:pPr>
             <a:r>
-              <a:rPr lang="en-US" sz="1900" b="1" dirty="0">
+              <a:rPr lang="en-US" sz="1700" b="1" dirty="0">
                 <a:solidFill>
                   <a:srgbClr val="E8833A"/>
                 </a:solidFill>
@@ -5519,9 +5621,9 @@
                 <a:ea typeface="Calibri" pitchFamily="34" charset="-122"/>
                 <a:cs typeface="Calibri" pitchFamily="34" charset="-120"/>
               </a:rPr>
-              <a:t>&lt; 5 GB</a:t>
+              <a:t>Sweet spot 1–1.5B</a:t>
             </a:r>
-            <a:endParaRPr lang="en-US" sz="1900" dirty="0"/>
+            <a:endParaRPr lang="en-US" sz="1700" dirty="0"/>
           </a:p>
         </p:txBody>
       </p:sp>
@@ -5550,7 +5652,7 @@
               <a:buNone/>
             </a:pPr>
             <a:r>
-              <a:rPr lang="en-US" sz="1200" dirty="0">
+              <a:rPr lang="en-US" sz="1150" dirty="0">
                 <a:solidFill>
                   <a:srgbClr val="D5E0EA"/>
                 </a:solidFill>
@@ -5558,9 +5660,9 @@
                 <a:ea typeface="Calibri" pitchFamily="34" charset="-122"/>
                 <a:cs typeface="Calibri" pitchFamily="34" charset="-120"/>
               </a:rPr>
-              <a:t>Tepe GPU belleği — full fine-tune 20+ GB isterdi</a:t>
+              <a:t>5B Gemma-4 küçük veride aşırı uydurma</a:t>
             </a:r>
-            <a:endParaRPr lang="en-US" sz="1200" dirty="0"/>
+            <a:endParaRPr lang="en-US" sz="1150" dirty="0"/>
           </a:p>
         </p:txBody>
       </p:sp>
@@ -5611,7 +5713,7 @@
               <a:buNone/>
             </a:pPr>
             <a:r>
-              <a:rPr lang="en-US" sz="1900" b="1" dirty="0">
+              <a:rPr lang="en-US" sz="1700" b="1" dirty="0">
                 <a:solidFill>
                   <a:srgbClr val="E8833A"/>
                 </a:solidFill>
@@ -5619,9 +5721,9 @@
                 <a:ea typeface="Calibri" pitchFamily="34" charset="-122"/>
                 <a:cs typeface="Calibri" pitchFamily="34" charset="-120"/>
               </a:rPr>
-              <a:t>En iyi: Qwen</a:t>
+              <a:t>TinyLlama verimli</a:t>
             </a:r>
-            <a:endParaRPr lang="en-US" sz="1900" dirty="0"/>
+            <a:endParaRPr lang="en-US" sz="1700" dirty="0"/>
           </a:p>
         </p:txBody>
       </p:sp>
@@ -5650,7 +5752,7 @@
               <a:buNone/>
             </a:pPr>
             <a:r>
-              <a:rPr lang="en-US" sz="1200" dirty="0">
+              <a:rPr lang="en-US" sz="1150" dirty="0">
                 <a:solidFill>
                   <a:srgbClr val="D5E0EA"/>
                 </a:solidFill>
@@ -5658,9 +5760,9 @@
                 <a:ea typeface="Calibri" pitchFamily="34" charset="-122"/>
                 <a:cs typeface="Calibri" pitchFamily="34" charset="-120"/>
               </a:rPr>
-              <a:t>TinyLlama ise en verimli (daha az GPU, ~eşit skor)</a:t>
+              <a:t>Qwen'e ~eşit skor, %35 daha az GPU</a:t>
             </a:r>
-            <a:endParaRPr lang="en-US" sz="1200" dirty="0"/>
+            <a:endParaRPr lang="en-US" sz="1150" dirty="0"/>
           </a:p>
         </p:txBody>
       </p:sp>
@@ -5689,7 +5791,7 @@
               <a:buNone/>
             </a:pPr>
             <a:r>
-              <a:rPr lang="en-US" sz="1400" i="1" dirty="0">
+              <a:rPr lang="en-US" sz="1300" i="1" dirty="0">
                 <a:solidFill>
                   <a:srgbClr val="AFC2D4"/>
                 </a:solidFill>
@@ -5697,9 +5799,9 @@
                 <a:ea typeface="Calibri" pitchFamily="34" charset="-122"/>
                 <a:cs typeface="Calibri" pitchFamily="34" charset="-120"/>
               </a:rPr>
-              <a:t>Gelecek: Gemma-4-E2B (4. model) · 3 seed ortalama±std · few-shot · tam LoRA–QLoRA karşılaştırması</a:t>
+              <a:t>Gelecek: Gemma-4 için modele özel hiperparametre · 3 seed ortalama±std · few-shot · tam LoRA–QLoRA karşılaştırması</a:t>
             </a:r>
-            <a:endParaRPr lang="en-US" sz="1400" dirty="0"/>
+            <a:endParaRPr lang="en-US" sz="1300" dirty="0"/>
           </a:p>
         </p:txBody>
       </p:sp>
@@ -7772,7 +7874,7 @@
         <p:spPr>
           <a:xfrm>
             <a:off x="640080" y="1645920"/>
-            <a:ext cx="6035040" cy="3657600"/>
+            <a:ext cx="6035040" cy="3840480"/>
           </a:xfrm>
           <a:prstGeom prst="rect">
             <a:avLst/>
@@ -7783,6 +7885,26 @@
         <p:txBody>
           <a:bodyPr wrap="square" rtlCol="0" anchor="t"/>
           <a:lstStyle/>
+          <a:p>
+            <a:pPr indent="0" marL="0">
+              <a:spcAft>
+                <a:spcPts val="800"/>
+              </a:spcAft>
+              <a:buNone/>
+            </a:pPr>
+            <a:r>
+              <a:rPr lang="en-US" sz="1350" dirty="0">
+                <a:solidFill>
+                  <a:srgbClr val="5B6B7B"/>
+                </a:solidFill>
+                <a:latin typeface="Calibri" pitchFamily="34" charset="0"/>
+                <a:ea typeface="Calibri" pitchFamily="34" charset="-122"/>
+                <a:cs typeface="Calibri" pitchFamily="34" charset="-120"/>
+              </a:rPr>
+              <a:t>Kaynak: Kaggle "Turkey Earthquake Relief Tweets" (Ulku Tuncer Küçüktaş, 2023).</a:t>
+            </a:r>
+            <a:endParaRPr lang="en-US" sz="1350" dirty="0"/>
+          </a:p>
           <a:p>
             <a:pPr indent="0" marL="0">
               <a:spcAft>
@@ -7799,9 +7921,9 @@
                 <a:ea typeface="Calibri" pitchFamily="34" charset="-122"/>
                 <a:cs typeface="Calibri" pitchFamily="34" charset="-120"/>
               </a:rPr>
-              <a:t>793 gerçek deprem tweet'i, beş sınıfa elle etiketlendi.</a:t>
+              <a:t>Bu havuzdan 793 tweet seçilip beş sınıfa elle etiketlendi.</a:t>
             </a:r>
-            <a:endParaRPr lang="en-US" sz="1600" dirty="0"/>
+            <a:endParaRPr lang="en-US" sz="1350" dirty="0"/>
           </a:p>
           <a:p>
             <a:pPr indent="0" marL="0">
@@ -7819,9 +7941,9 @@
                 <a:ea typeface="Calibri" pitchFamily="34" charset="-122"/>
                 <a:cs typeface="Calibri" pitchFamily="34" charset="-120"/>
               </a:rPr>
-              <a:t>Zayıf etiketleme ve sentetik üretim denendi; etiket kalitesi için elle etiketli set tercih edildi (dürüstlük beyanı raporda).</a:t>
+              <a:t>Ham metin Kaggle'dan; 5 sınıflı etiketler bu çalışmaya özgü. Zayıf/sentetik etiketleme denendi, kalite için elle etiketli set tercih edildi.</a:t>
             </a:r>
-            <a:endParaRPr lang="en-US" sz="1600" dirty="0"/>
+            <a:endParaRPr lang="en-US" sz="1350" dirty="0"/>
           </a:p>
           <a:p>
             <a:pPr indent="0" marL="0">
@@ -7841,7 +7963,7 @@
               </a:rPr>
               <a:t>Ön işleme: URL/@kullanıcı anonimleştirme, boşluk normalizasyonu. Türkçe karakter, hashtag, emoji korundu.</a:t>
             </a:r>
-            <a:endParaRPr lang="en-US" sz="1600" dirty="0"/>
+            <a:endParaRPr lang="en-US" sz="1350" dirty="0"/>
           </a:p>
           <a:p>
             <a:pPr indent="0" marL="0">
@@ -7858,7 +7980,7 @@
               </a:rPr>
               <a:t>Bölme: %80/10/10 stratified → 633 / 80 / 80 · seed=42</a:t>
             </a:r>
-            <a:endParaRPr lang="en-US" sz="1600" dirty="0"/>
+            <a:endParaRPr lang="en-US" sz="1350" dirty="0"/>
           </a:p>
         </p:txBody>
       </p:sp>
@@ -8983,15 +9105,15 @@
                         <a:buNone/>
                       </a:pPr>
                       <a:r>
-                        <a:rPr lang="en-US" sz="1300" i="1" dirty="0">
+                        <a:rPr lang="en-US" sz="1300" dirty="0">
                           <a:solidFill>
-                            <a:srgbClr val="5B6B7B"/>
+                            <a:srgbClr val="000000"/>
                           </a:solidFill>
                           <a:latin typeface="Calibri" pitchFamily="34" charset="0"/>
                           <a:ea typeface="Calibri" pitchFamily="34" charset="-122"/>
                           <a:cs typeface="Calibri" pitchFamily="34" charset="-120"/>
                         </a:rPr>
-                        <a:t>Gemma-4-E2B-it (planlanan)</a:t>
+                        <a:t>Gemma-4-E2B-it (Unsloth)</a:t>
                       </a:r>
                       <a:endParaRPr lang="en-US" sz="1300" dirty="0">
                         <a:latin typeface="Calibri" charset="0"/>
@@ -9051,15 +9173,15 @@
                         <a:buNone/>
                       </a:pPr>
                       <a:r>
-                        <a:rPr lang="en-US" sz="1300" i="1" dirty="0">
+                        <a:rPr lang="en-US" sz="1300" dirty="0">
                           <a:solidFill>
-                            <a:srgbClr val="5B6B7B"/>
+                            <a:srgbClr val="000000"/>
                           </a:solidFill>
                           <a:latin typeface="Calibri" pitchFamily="34" charset="0"/>
                           <a:ea typeface="Calibri" pitchFamily="34" charset="-122"/>
                           <a:cs typeface="Calibri" pitchFamily="34" charset="-120"/>
                         </a:rPr>
-                        <a:t>~2B</a:t>
+                        <a:t>5B / ~2B</a:t>
                       </a:r>
                       <a:endParaRPr lang="en-US" sz="1300" dirty="0">
                         <a:latin typeface="Calibri" charset="0"/>
@@ -9477,7 +9599,7 @@
                 <a:gridCol w="1737360"/>
                 <a:gridCol w="1645920"/>
               </a:tblGrid>
-              <a:tr h="566928">
+              <a:tr h="493776">
                 <a:tc>
                   <a:txBody>
                     <a:bodyPr/>
@@ -9487,7 +9609,7 @@
                         <a:buNone/>
                       </a:pPr>
                       <a:r>
-                        <a:rPr lang="en-US" sz="1400" b="1" dirty="0">
+                        <a:rPr lang="en-US" sz="1300" b="1" dirty="0">
                           <a:solidFill>
                             <a:srgbClr val="FFFFFF"/>
                           </a:solidFill>
@@ -9497,7 +9619,7 @@
                         </a:rPr>
                         <a:t>Model</a:t>
                       </a:r>
-                      <a:endParaRPr lang="en-US" sz="1400" dirty="0">
+                      <a:endParaRPr lang="en-US" sz="1300" dirty="0">
                         <a:latin typeface="Calibri" charset="0"/>
                         <a:ea typeface="Calibri" charset="0"/>
                         <a:cs typeface="Calibri" charset="0"/>
@@ -9555,7 +9677,7 @@
                         <a:buNone/>
                       </a:pPr>
                       <a:r>
-                        <a:rPr lang="en-US" sz="1400" b="1" dirty="0">
+                        <a:rPr lang="en-US" sz="1300" b="1" dirty="0">
                           <a:solidFill>
                             <a:srgbClr val="FFFFFF"/>
                           </a:solidFill>
@@ -9565,7 +9687,7 @@
                         </a:rPr>
                         <a:t>Yöntem</a:t>
                       </a:r>
-                      <a:endParaRPr lang="en-US" sz="1400" dirty="0">
+                      <a:endParaRPr lang="en-US" sz="1300" dirty="0">
                         <a:latin typeface="Calibri" charset="0"/>
                         <a:ea typeface="Calibri" charset="0"/>
                         <a:cs typeface="Calibri" charset="0"/>
@@ -9623,7 +9745,7 @@
                         <a:buNone/>
                       </a:pPr>
                       <a:r>
-                        <a:rPr lang="en-US" sz="1400" b="1" dirty="0">
+                        <a:rPr lang="en-US" sz="1300" b="1" dirty="0">
                           <a:solidFill>
                             <a:srgbClr val="FFFFFF"/>
                           </a:solidFill>
@@ -9633,7 +9755,7 @@
                         </a:rPr>
                         <a:t>Acc</a:t>
                       </a:r>
-                      <a:endParaRPr lang="en-US" sz="1400" dirty="0">
+                      <a:endParaRPr lang="en-US" sz="1300" dirty="0">
                         <a:latin typeface="Calibri" charset="0"/>
                         <a:ea typeface="Calibri" charset="0"/>
                         <a:cs typeface="Calibri" charset="0"/>
@@ -9691,7 +9813,7 @@
                         <a:buNone/>
                       </a:pPr>
                       <a:r>
-                        <a:rPr lang="en-US" sz="1400" b="1" dirty="0">
+                        <a:rPr lang="en-US" sz="1300" b="1" dirty="0">
                           <a:solidFill>
                             <a:srgbClr val="FFFFFF"/>
                           </a:solidFill>
@@ -9701,7 +9823,7 @@
                         </a:rPr>
                         <a:t>Macro-F1</a:t>
                       </a:r>
-                      <a:endParaRPr lang="en-US" sz="1400" dirty="0">
+                      <a:endParaRPr lang="en-US" sz="1300" dirty="0">
                         <a:latin typeface="Calibri" charset="0"/>
                         <a:ea typeface="Calibri" charset="0"/>
                         <a:cs typeface="Calibri" charset="0"/>
@@ -9759,7 +9881,7 @@
                         <a:buNone/>
                       </a:pPr>
                       <a:r>
-                        <a:rPr lang="en-US" sz="1400" b="1" dirty="0">
+                        <a:rPr lang="en-US" sz="1300" b="1" dirty="0">
                           <a:solidFill>
                             <a:srgbClr val="FFFFFF"/>
                           </a:solidFill>
@@ -9769,7 +9891,7 @@
                         </a:rPr>
                         <a:t>Weig-F1</a:t>
                       </a:r>
-                      <a:endParaRPr lang="en-US" sz="1400" dirty="0">
+                      <a:endParaRPr lang="en-US" sz="1300" dirty="0">
                         <a:latin typeface="Calibri" charset="0"/>
                         <a:ea typeface="Calibri" charset="0"/>
                         <a:cs typeface="Calibri" charset="0"/>
@@ -9827,7 +9949,7 @@
                         <a:buNone/>
                       </a:pPr>
                       <a:r>
-                        <a:rPr lang="en-US" sz="1400" b="1" dirty="0">
+                        <a:rPr lang="en-US" sz="1300" b="1" dirty="0">
                           <a:solidFill>
                             <a:srgbClr val="FFFFFF"/>
                           </a:solidFill>
@@ -9837,7 +9959,7 @@
                         </a:rPr>
                         <a:t>GPU (GB)</a:t>
                       </a:r>
-                      <a:endParaRPr lang="en-US" sz="1400" dirty="0">
+                      <a:endParaRPr lang="en-US" sz="1300" dirty="0">
                         <a:latin typeface="Calibri" charset="0"/>
                         <a:ea typeface="Calibri" charset="0"/>
                         <a:cs typeface="Calibri" charset="0"/>
@@ -9887,7 +10009,7 @@
                   </a:tcPr>
                 </a:tc>
               </a:tr>
-              <a:tr h="566928">
+              <a:tr h="493776">
                 <a:tc>
                   <a:txBody>
                     <a:bodyPr/>
@@ -9897,7 +10019,7 @@
                         <a:buNone/>
                       </a:pPr>
                       <a:r>
-                        <a:rPr lang="en-US" sz="1300" dirty="0">
+                        <a:rPr lang="en-US" sz="1200" dirty="0">
                           <a:solidFill>
                             <a:srgbClr val="000000"/>
                           </a:solidFill>
@@ -9907,7 +10029,7 @@
                         </a:rPr>
                         <a:t>TinyLlama-1.1B</a:t>
                       </a:r>
-                      <a:endParaRPr lang="en-US" sz="1300" dirty="0">
+                      <a:endParaRPr lang="en-US" sz="1200" dirty="0">
                         <a:latin typeface="Calibri" charset="0"/>
                         <a:ea typeface="Calibri" charset="0"/>
                         <a:cs typeface="Calibri" charset="0"/>
@@ -9965,7 +10087,7 @@
                         <a:buNone/>
                       </a:pPr>
                       <a:r>
-                        <a:rPr lang="en-US" sz="1300" dirty="0">
+                        <a:rPr lang="en-US" sz="1200" dirty="0">
                           <a:solidFill>
                             <a:srgbClr val="C0392B"/>
                           </a:solidFill>
@@ -9975,7 +10097,7 @@
                         </a:rPr>
                         <a:t>Zero-shot</a:t>
                       </a:r>
-                      <a:endParaRPr lang="en-US" sz="1300" dirty="0">
+                      <a:endParaRPr lang="en-US" sz="1200" dirty="0">
                         <a:latin typeface="Calibri" charset="0"/>
                         <a:ea typeface="Calibri" charset="0"/>
                         <a:cs typeface="Calibri" charset="0"/>
@@ -10033,7 +10155,7 @@
                         <a:buNone/>
                       </a:pPr>
                       <a:r>
-                        <a:rPr lang="en-US" sz="1300" dirty="0">
+                        <a:rPr lang="en-US" sz="1200" dirty="0">
                           <a:solidFill>
                             <a:srgbClr val="000000"/>
                           </a:solidFill>
@@ -10043,7 +10165,7 @@
                         </a:rPr>
                         <a:t>0.262</a:t>
                       </a:r>
-                      <a:endParaRPr lang="en-US" sz="1300" dirty="0">
+                      <a:endParaRPr lang="en-US" sz="1200" dirty="0">
                         <a:latin typeface="Calibri" charset="0"/>
                         <a:ea typeface="Calibri" charset="0"/>
                         <a:cs typeface="Calibri" charset="0"/>
@@ -10101,7 +10223,7 @@
                         <a:buNone/>
                       </a:pPr>
                       <a:r>
-                        <a:rPr lang="en-US" sz="1300" b="1" dirty="0">
+                        <a:rPr lang="en-US" sz="1200" b="1" dirty="0">
                           <a:solidFill>
                             <a:srgbClr val="C0392B"/>
                           </a:solidFill>
@@ -10111,7 +10233,7 @@
                         </a:rPr>
                         <a:t>0.094</a:t>
                       </a:r>
-                      <a:endParaRPr lang="en-US" sz="1300" dirty="0">
+                      <a:endParaRPr lang="en-US" sz="1200" dirty="0">
                         <a:latin typeface="Calibri" charset="0"/>
                         <a:ea typeface="Calibri" charset="0"/>
                         <a:cs typeface="Calibri" charset="0"/>
@@ -10169,7 +10291,7 @@
                         <a:buNone/>
                       </a:pPr>
                       <a:r>
-                        <a:rPr lang="en-US" sz="1300" dirty="0">
+                        <a:rPr lang="en-US" sz="1200" dirty="0">
                           <a:solidFill>
                             <a:srgbClr val="000000"/>
                           </a:solidFill>
@@ -10179,7 +10301,7 @@
                         </a:rPr>
                         <a:t>0.125</a:t>
                       </a:r>
-                      <a:endParaRPr lang="en-US" sz="1300" dirty="0">
+                      <a:endParaRPr lang="en-US" sz="1200" dirty="0">
                         <a:latin typeface="Calibri" charset="0"/>
                         <a:ea typeface="Calibri" charset="0"/>
                         <a:cs typeface="Calibri" charset="0"/>
@@ -10237,7 +10359,7 @@
                         <a:buNone/>
                       </a:pPr>
                       <a:r>
-                        <a:rPr lang="en-US" sz="1300" dirty="0">
+                        <a:rPr lang="en-US" sz="1200" dirty="0">
                           <a:solidFill>
                             <a:srgbClr val="000000"/>
                           </a:solidFill>
@@ -10247,7 +10369,7 @@
                         </a:rPr>
                         <a:t>—</a:t>
                       </a:r>
-                      <a:endParaRPr lang="en-US" sz="1300" dirty="0">
+                      <a:endParaRPr lang="en-US" sz="1200" dirty="0">
                         <a:latin typeface="Calibri" charset="0"/>
                         <a:ea typeface="Calibri" charset="0"/>
                         <a:cs typeface="Calibri" charset="0"/>
@@ -10297,7 +10419,7 @@
                   </a:tcPr>
                 </a:tc>
               </a:tr>
-              <a:tr h="566928">
+              <a:tr h="493776">
                 <a:tc>
                   <a:txBody>
                     <a:bodyPr/>
@@ -10307,7 +10429,7 @@
                         <a:buNone/>
                       </a:pPr>
                       <a:r>
-                        <a:rPr lang="en-US" sz="1300" dirty="0">
+                        <a:rPr lang="en-US" sz="1200" dirty="0">
                           <a:solidFill>
                             <a:srgbClr val="000000"/>
                           </a:solidFill>
@@ -10317,7 +10439,7 @@
                         </a:rPr>
                         <a:t>SmolLM2-360M</a:t>
                       </a:r>
-                      <a:endParaRPr lang="en-US" sz="1300" dirty="0">
+                      <a:endParaRPr lang="en-US" sz="1200" dirty="0">
                         <a:latin typeface="Calibri" charset="0"/>
                         <a:ea typeface="Calibri" charset="0"/>
                         <a:cs typeface="Calibri" charset="0"/>
@@ -10375,7 +10497,7 @@
                         <a:buNone/>
                       </a:pPr>
                       <a:r>
-                        <a:rPr lang="en-US" sz="1300" dirty="0">
+                        <a:rPr lang="en-US" sz="1200" dirty="0">
                           <a:solidFill>
                             <a:srgbClr val="000000"/>
                           </a:solidFill>
@@ -10385,7 +10507,7 @@
                         </a:rPr>
                         <a:t>QLoRA</a:t>
                       </a:r>
-                      <a:endParaRPr lang="en-US" sz="1300" dirty="0">
+                      <a:endParaRPr lang="en-US" sz="1200" dirty="0">
                         <a:latin typeface="Calibri" charset="0"/>
                         <a:ea typeface="Calibri" charset="0"/>
                         <a:cs typeface="Calibri" charset="0"/>
@@ -10443,7 +10565,7 @@
                         <a:buNone/>
                       </a:pPr>
                       <a:r>
-                        <a:rPr lang="en-US" sz="1300" dirty="0">
+                        <a:rPr lang="en-US" sz="1200" dirty="0">
                           <a:solidFill>
                             <a:srgbClr val="000000"/>
                           </a:solidFill>
@@ -10453,7 +10575,7 @@
                         </a:rPr>
                         <a:t>0.662</a:t>
                       </a:r>
-                      <a:endParaRPr lang="en-US" sz="1300" dirty="0">
+                      <a:endParaRPr lang="en-US" sz="1200" dirty="0">
                         <a:latin typeface="Calibri" charset="0"/>
                         <a:ea typeface="Calibri" charset="0"/>
                         <a:cs typeface="Calibri" charset="0"/>
@@ -10511,7 +10633,7 @@
                         <a:buNone/>
                       </a:pPr>
                       <a:r>
-                        <a:rPr lang="en-US" sz="1300" dirty="0">
+                        <a:rPr lang="en-US" sz="1200" dirty="0">
                           <a:solidFill>
                             <a:srgbClr val="000000"/>
                           </a:solidFill>
@@ -10521,7 +10643,7 @@
                         </a:rPr>
                         <a:t>0.588</a:t>
                       </a:r>
-                      <a:endParaRPr lang="en-US" sz="1300" dirty="0">
+                      <a:endParaRPr lang="en-US" sz="1200" dirty="0">
                         <a:latin typeface="Calibri" charset="0"/>
                         <a:ea typeface="Calibri" charset="0"/>
                         <a:cs typeface="Calibri" charset="0"/>
@@ -10579,7 +10701,7 @@
                         <a:buNone/>
                       </a:pPr>
                       <a:r>
-                        <a:rPr lang="en-US" sz="1300" dirty="0">
+                        <a:rPr lang="en-US" sz="1200" dirty="0">
                           <a:solidFill>
                             <a:srgbClr val="000000"/>
                           </a:solidFill>
@@ -10589,7 +10711,7 @@
                         </a:rPr>
                         <a:t>0.663</a:t>
                       </a:r>
-                      <a:endParaRPr lang="en-US" sz="1300" dirty="0">
+                      <a:endParaRPr lang="en-US" sz="1200" dirty="0">
                         <a:latin typeface="Calibri" charset="0"/>
                         <a:ea typeface="Calibri" charset="0"/>
                         <a:cs typeface="Calibri" charset="0"/>
@@ -10647,7 +10769,7 @@
                         <a:buNone/>
                       </a:pPr>
                       <a:r>
-                        <a:rPr lang="en-US" sz="1300" dirty="0">
+                        <a:rPr lang="en-US" sz="1200" dirty="0">
                           <a:solidFill>
                             <a:srgbClr val="000000"/>
                           </a:solidFill>
@@ -10657,7 +10779,7 @@
                         </a:rPr>
                         <a:t>1.81</a:t>
                       </a:r>
-                      <a:endParaRPr lang="en-US" sz="1300" dirty="0">
+                      <a:endParaRPr lang="en-US" sz="1200" dirty="0">
                         <a:latin typeface="Calibri" charset="0"/>
                         <a:ea typeface="Calibri" charset="0"/>
                         <a:cs typeface="Calibri" charset="0"/>
@@ -10707,7 +10829,7 @@
                   </a:tcPr>
                 </a:tc>
               </a:tr>
-              <a:tr h="566928">
+              <a:tr h="493776">
                 <a:tc>
                   <a:txBody>
                     <a:bodyPr/>
@@ -10717,7 +10839,7 @@
                         <a:buNone/>
                       </a:pPr>
                       <a:r>
-                        <a:rPr lang="en-US" sz="1300" b="1" dirty="0">
+                        <a:rPr lang="en-US" sz="1200" b="1" dirty="0">
                           <a:solidFill>
                             <a:srgbClr val="000000"/>
                           </a:solidFill>
@@ -10727,7 +10849,7 @@
                         </a:rPr>
                         <a:t>TinyLlama-1.1B</a:t>
                       </a:r>
-                      <a:endParaRPr lang="en-US" sz="1300" dirty="0">
+                      <a:endParaRPr lang="en-US" sz="1200" dirty="0">
                         <a:latin typeface="Calibri" charset="0"/>
                         <a:ea typeface="Calibri" charset="0"/>
                         <a:cs typeface="Calibri" charset="0"/>
@@ -10785,7 +10907,7 @@
                         <a:buNone/>
                       </a:pPr>
                       <a:r>
-                        <a:rPr lang="en-US" sz="1300" b="1" dirty="0">
+                        <a:rPr lang="en-US" sz="1200" b="1" dirty="0">
                           <a:solidFill>
                             <a:srgbClr val="000000"/>
                           </a:solidFill>
@@ -10795,7 +10917,7 @@
                         </a:rPr>
                         <a:t>QLoRA</a:t>
                       </a:r>
-                      <a:endParaRPr lang="en-US" sz="1300" dirty="0">
+                      <a:endParaRPr lang="en-US" sz="1200" dirty="0">
                         <a:latin typeface="Calibri" charset="0"/>
                         <a:ea typeface="Calibri" charset="0"/>
                         <a:cs typeface="Calibri" charset="0"/>
@@ -10853,7 +10975,7 @@
                         <a:buNone/>
                       </a:pPr>
                       <a:r>
-                        <a:rPr lang="en-US" sz="1300" b="1" dirty="0">
+                        <a:rPr lang="en-US" sz="1200" b="1" dirty="0">
                           <a:solidFill>
                             <a:srgbClr val="000000"/>
                           </a:solidFill>
@@ -10863,7 +10985,7 @@
                         </a:rPr>
                         <a:t>0.925</a:t>
                       </a:r>
-                      <a:endParaRPr lang="en-US" sz="1300" dirty="0">
+                      <a:endParaRPr lang="en-US" sz="1200" dirty="0">
                         <a:latin typeface="Calibri" charset="0"/>
                         <a:ea typeface="Calibri" charset="0"/>
                         <a:cs typeface="Calibri" charset="0"/>
@@ -10921,7 +11043,7 @@
                         <a:buNone/>
                       </a:pPr>
                       <a:r>
-                        <a:rPr lang="en-US" sz="1300" b="1" dirty="0">
+                        <a:rPr lang="en-US" sz="1200" b="1" dirty="0">
                           <a:solidFill>
                             <a:srgbClr val="000000"/>
                           </a:solidFill>
@@ -10931,7 +11053,7 @@
                         </a:rPr>
                         <a:t>0.908</a:t>
                       </a:r>
-                      <a:endParaRPr lang="en-US" sz="1300" dirty="0">
+                      <a:endParaRPr lang="en-US" sz="1200" dirty="0">
                         <a:latin typeface="Calibri" charset="0"/>
                         <a:ea typeface="Calibri" charset="0"/>
                         <a:cs typeface="Calibri" charset="0"/>
@@ -10989,7 +11111,7 @@
                         <a:buNone/>
                       </a:pPr>
                       <a:r>
-                        <a:rPr lang="en-US" sz="1300" b="1" dirty="0">
+                        <a:rPr lang="en-US" sz="1200" b="1" dirty="0">
                           <a:solidFill>
                             <a:srgbClr val="000000"/>
                           </a:solidFill>
@@ -10999,7 +11121,7 @@
                         </a:rPr>
                         <a:t>0.921</a:t>
                       </a:r>
-                      <a:endParaRPr lang="en-US" sz="1300" dirty="0">
+                      <a:endParaRPr lang="en-US" sz="1200" dirty="0">
                         <a:latin typeface="Calibri" charset="0"/>
                         <a:ea typeface="Calibri" charset="0"/>
                         <a:cs typeface="Calibri" charset="0"/>
@@ -11057,7 +11179,7 @@
                         <a:buNone/>
                       </a:pPr>
                       <a:r>
-                        <a:rPr lang="en-US" sz="1300" b="1" dirty="0">
+                        <a:rPr lang="en-US" sz="1200" b="1" dirty="0">
                           <a:solidFill>
                             <a:srgbClr val="000000"/>
                           </a:solidFill>
@@ -11067,7 +11189,7 @@
                         </a:rPr>
                         <a:t>3.29</a:t>
                       </a:r>
-                      <a:endParaRPr lang="en-US" sz="1300" dirty="0">
+                      <a:endParaRPr lang="en-US" sz="1200" dirty="0">
                         <a:latin typeface="Calibri" charset="0"/>
                         <a:ea typeface="Calibri" charset="0"/>
                         <a:cs typeface="Calibri" charset="0"/>
@@ -11117,7 +11239,7 @@
                   </a:tcPr>
                 </a:tc>
               </a:tr>
-              <a:tr h="566928">
+              <a:tr h="493776">
                 <a:tc>
                   <a:txBody>
                     <a:bodyPr/>
@@ -11127,7 +11249,7 @@
                         <a:buNone/>
                       </a:pPr>
                       <a:r>
-                        <a:rPr lang="en-US" sz="1300" b="1" dirty="0">
+                        <a:rPr lang="en-US" sz="1200" b="1" dirty="0">
                           <a:solidFill>
                             <a:srgbClr val="000000"/>
                           </a:solidFill>
@@ -11137,7 +11259,143 @@
                         </a:rPr>
                         <a:t>Qwen2.5-1.5B</a:t>
                       </a:r>
-                      <a:endParaRPr lang="en-US" sz="1300" dirty="0">
+                      <a:endParaRPr lang="en-US" sz="1200" dirty="0">
+                        <a:latin typeface="Calibri" charset="0"/>
+                        <a:ea typeface="Calibri" charset="0"/>
+                        <a:cs typeface="Calibri" charset="0"/>
+                      </a:endParaRPr>
+                    </a:p>
+                  </a:txBody>
+                  <a:tcPr marL="91440" marR="91440" marT="45720" marB="45720" anchor="ctr">
+                    <a:lnL w="12700" cap="flat" cmpd="sng" algn="ctr">
+                      <a:solidFill>
+                        <a:srgbClr val="D9E1E8"/>
+                      </a:solidFill>
+                      <a:prstDash val="solid"/>
+                      <a:round/>
+                      <a:headEnd type="none" w="med" len="med"/>
+                      <a:tailEnd type="none" w="med" len="med"/>
+                    </a:lnL>
+                    <a:lnR w="12700" cap="flat" cmpd="sng" algn="ctr">
+                      <a:solidFill>
+                        <a:srgbClr val="D9E1E8"/>
+                      </a:solidFill>
+                      <a:prstDash val="solid"/>
+                      <a:round/>
+                      <a:headEnd type="none" w="med" len="med"/>
+                      <a:tailEnd type="none" w="med" len="med"/>
+                    </a:lnR>
+                    <a:lnT w="12700" cap="flat" cmpd="sng" algn="ctr">
+                      <a:solidFill>
+                        <a:srgbClr val="D9E1E8"/>
+                      </a:solidFill>
+                      <a:prstDash val="solid"/>
+                      <a:round/>
+                      <a:headEnd type="none" w="med" len="med"/>
+                      <a:tailEnd type="none" w="med" len="med"/>
+                    </a:lnT>
+                    <a:lnB w="12700" cap="flat" cmpd="sng" algn="ctr">
+                      <a:solidFill>
+                        <a:srgbClr val="D9E1E8"/>
+                      </a:solidFill>
+                      <a:prstDash val="solid"/>
+                      <a:round/>
+                      <a:headEnd type="none" w="med" len="med"/>
+                      <a:tailEnd type="none" w="med" len="med"/>
+                    </a:lnB>
+                    <a:solidFill>
+                      <a:srgbClr val="E2EFDA"/>
+                    </a:solidFill>
+                  </a:tcPr>
+                </a:tc>
+                <a:tc>
+                  <a:txBody>
+                    <a:bodyPr/>
+                    <a:lstStyle/>
+                    <a:p>
+                      <a:pPr algn="ctr" indent="0" marL="0">
+                        <a:buNone/>
+                      </a:pPr>
+                      <a:r>
+                        <a:rPr lang="en-US" sz="1200" b="1" dirty="0">
+                          <a:solidFill>
+                            <a:srgbClr val="000000"/>
+                          </a:solidFill>
+                          <a:latin typeface="Calibri" pitchFamily="34" charset="0"/>
+                          <a:ea typeface="Calibri" pitchFamily="34" charset="-122"/>
+                          <a:cs typeface="Calibri" pitchFamily="34" charset="-120"/>
+                        </a:rPr>
+                        <a:t>QLoRA</a:t>
+                      </a:r>
+                      <a:endParaRPr lang="en-US" sz="1200" dirty="0">
+                        <a:latin typeface="Calibri" charset="0"/>
+                        <a:ea typeface="Calibri" charset="0"/>
+                        <a:cs typeface="Calibri" charset="0"/>
+                      </a:endParaRPr>
+                    </a:p>
+                  </a:txBody>
+                  <a:tcPr marL="91440" marR="91440" marT="45720" marB="45720" anchor="ctr">
+                    <a:lnL w="12700" cap="flat" cmpd="sng" algn="ctr">
+                      <a:solidFill>
+                        <a:srgbClr val="D9E1E8"/>
+                      </a:solidFill>
+                      <a:prstDash val="solid"/>
+                      <a:round/>
+                      <a:headEnd type="none" w="med" len="med"/>
+                      <a:tailEnd type="none" w="med" len="med"/>
+                    </a:lnL>
+                    <a:lnR w="12700" cap="flat" cmpd="sng" algn="ctr">
+                      <a:solidFill>
+                        <a:srgbClr val="D9E1E8"/>
+                      </a:solidFill>
+                      <a:prstDash val="solid"/>
+                      <a:round/>
+                      <a:headEnd type="none" w="med" len="med"/>
+                      <a:tailEnd type="none" w="med" len="med"/>
+                    </a:lnR>
+                    <a:lnT w="12700" cap="flat" cmpd="sng" algn="ctr">
+                      <a:solidFill>
+                        <a:srgbClr val="D9E1E8"/>
+                      </a:solidFill>
+                      <a:prstDash val="solid"/>
+                      <a:round/>
+                      <a:headEnd type="none" w="med" len="med"/>
+                      <a:tailEnd type="none" w="med" len="med"/>
+                    </a:lnT>
+                    <a:lnB w="12700" cap="flat" cmpd="sng" algn="ctr">
+                      <a:solidFill>
+                        <a:srgbClr val="D9E1E8"/>
+                      </a:solidFill>
+                      <a:prstDash val="solid"/>
+                      <a:round/>
+                      <a:headEnd type="none" w="med" len="med"/>
+                      <a:tailEnd type="none" w="med" len="med"/>
+                    </a:lnB>
+                    <a:solidFill>
+                      <a:srgbClr val="E2EFDA"/>
+                    </a:solidFill>
+                  </a:tcPr>
+                </a:tc>
+                <a:tc>
+                  <a:txBody>
+                    <a:bodyPr/>
+                    <a:lstStyle/>
+                    <a:p>
+                      <a:pPr algn="ctr" indent="0" marL="0">
+                        <a:buNone/>
+                      </a:pPr>
+                      <a:r>
+                        <a:rPr lang="en-US" sz="1200" b="1" dirty="0">
+                          <a:solidFill>
+                            <a:srgbClr val="000000"/>
+                          </a:solidFill>
+                          <a:latin typeface="Calibri" pitchFamily="34" charset="0"/>
+                          <a:ea typeface="Calibri" pitchFamily="34" charset="-122"/>
+                          <a:cs typeface="Calibri" pitchFamily="34" charset="-120"/>
+                        </a:rPr>
+                        <a:t>0.925</a:t>
+                      </a:r>
+                      <a:endParaRPr lang="en-US" sz="1200" dirty="0">
                         <a:latin typeface="Calibri" charset="0"/>
                         <a:ea typeface="Calibri" charset="0"/>
                         <a:cs typeface="Calibri" charset="0"/>
@@ -11197,13 +11455,13 @@
                       <a:r>
                         <a:rPr lang="en-US" sz="1300" b="1" dirty="0">
                           <a:solidFill>
-                            <a:srgbClr val="000000"/>
+                            <a:srgbClr val="2E7D32"/>
                           </a:solidFill>
                           <a:latin typeface="Calibri" pitchFamily="34" charset="0"/>
                           <a:ea typeface="Calibri" pitchFamily="34" charset="-122"/>
                           <a:cs typeface="Calibri" pitchFamily="34" charset="-120"/>
                         </a:rPr>
-                        <a:t>QLoRA</a:t>
+                        <a:t>0.914</a:t>
                       </a:r>
                       <a:endParaRPr lang="en-US" sz="1300" dirty="0">
                         <a:latin typeface="Calibri" charset="0"/>
@@ -11263,7 +11521,7 @@
                         <a:buNone/>
                       </a:pPr>
                       <a:r>
-                        <a:rPr lang="en-US" sz="1300" b="1" dirty="0">
+                        <a:rPr lang="en-US" sz="1200" b="1" dirty="0">
                           <a:solidFill>
                             <a:srgbClr val="000000"/>
                           </a:solidFill>
@@ -11273,7 +11531,7 @@
                         </a:rPr>
                         <a:t>0.925</a:t>
                       </a:r>
-                      <a:endParaRPr lang="en-US" sz="1300" dirty="0">
+                      <a:endParaRPr lang="en-US" sz="1200" dirty="0">
                         <a:latin typeface="Calibri" charset="0"/>
                         <a:ea typeface="Calibri" charset="0"/>
                         <a:cs typeface="Calibri" charset="0"/>
@@ -11331,17 +11589,17 @@
                         <a:buNone/>
                       </a:pPr>
                       <a:r>
-                        <a:rPr lang="en-US" sz="1400" b="1" dirty="0">
+                        <a:rPr lang="en-US" sz="1200" dirty="0">
                           <a:solidFill>
-                            <a:srgbClr val="2E7D32"/>
+                            <a:srgbClr val="000000"/>
                           </a:solidFill>
                           <a:latin typeface="Calibri" pitchFamily="34" charset="0"/>
                           <a:ea typeface="Calibri" pitchFamily="34" charset="-122"/>
                           <a:cs typeface="Calibri" pitchFamily="34" charset="-120"/>
                         </a:rPr>
-                        <a:t>0.914</a:t>
+                        <a:t>5.07</a:t>
                       </a:r>
-                      <a:endParaRPr lang="en-US" sz="1400" dirty="0">
+                      <a:endParaRPr lang="en-US" sz="1200" dirty="0">
                         <a:latin typeface="Calibri" charset="0"/>
                         <a:ea typeface="Calibri" charset="0"/>
                         <a:cs typeface="Calibri" charset="0"/>
@@ -11387,6 +11645,76 @@
                     </a:lnB>
                     <a:solidFill>
                       <a:srgbClr val="E2EFDA"/>
+                    </a:solidFill>
+                  </a:tcPr>
+                </a:tc>
+              </a:tr>
+              <a:tr h="493776">
+                <a:tc>
+                  <a:txBody>
+                    <a:bodyPr/>
+                    <a:lstStyle/>
+                    <a:p>
+                      <a:pPr indent="0" marL="0">
+                        <a:buNone/>
+                      </a:pPr>
+                      <a:r>
+                        <a:rPr lang="en-US" sz="1200" dirty="0">
+                          <a:solidFill>
+                            <a:srgbClr val="000000"/>
+                          </a:solidFill>
+                          <a:latin typeface="Calibri" pitchFamily="34" charset="0"/>
+                          <a:ea typeface="Calibri" pitchFamily="34" charset="-122"/>
+                          <a:cs typeface="Calibri" pitchFamily="34" charset="-120"/>
+                        </a:rPr>
+                        <a:t>Gemma-4-E2B (5B)</a:t>
+                      </a:r>
+                      <a:endParaRPr lang="en-US" sz="1200" dirty="0">
+                        <a:latin typeface="Calibri" charset="0"/>
+                        <a:ea typeface="Calibri" charset="0"/>
+                        <a:cs typeface="Calibri" charset="0"/>
+                      </a:endParaRPr>
+                    </a:p>
+                  </a:txBody>
+                  <a:tcPr marL="91440" marR="91440" marT="45720" marB="45720" anchor="ctr">
+                    <a:lnL w="12700" cap="flat" cmpd="sng" algn="ctr">
+                      <a:solidFill>
+                        <a:srgbClr val="D9E1E8"/>
+                      </a:solidFill>
+                      <a:prstDash val="solid"/>
+                      <a:round/>
+                      <a:headEnd type="none" w="med" len="med"/>
+                      <a:tailEnd type="none" w="med" len="med"/>
+                    </a:lnL>
+                    <a:lnR w="12700" cap="flat" cmpd="sng" algn="ctr">
+                      <a:solidFill>
+                        <a:srgbClr val="D9E1E8"/>
+                      </a:solidFill>
+                      <a:prstDash val="solid"/>
+                      <a:round/>
+                      <a:headEnd type="none" w="med" len="med"/>
+                      <a:tailEnd type="none" w="med" len="med"/>
+                    </a:lnR>
+                    <a:lnT w="12700" cap="flat" cmpd="sng" algn="ctr">
+                      <a:solidFill>
+                        <a:srgbClr val="D9E1E8"/>
+                      </a:solidFill>
+                      <a:prstDash val="solid"/>
+                      <a:round/>
+                      <a:headEnd type="none" w="med" len="med"/>
+                      <a:tailEnd type="none" w="med" len="med"/>
+                    </a:lnT>
+                    <a:lnB w="12700" cap="flat" cmpd="sng" algn="ctr">
+                      <a:solidFill>
+                        <a:srgbClr val="D9E1E8"/>
+                      </a:solidFill>
+                      <a:prstDash val="solid"/>
+                      <a:round/>
+                      <a:headEnd type="none" w="med" len="med"/>
+                      <a:tailEnd type="none" w="med" len="med"/>
+                    </a:lnB>
+                    <a:solidFill>
+                      <a:srgbClr val="FFFFFF"/>
                     </a:solidFill>
                   </a:tcPr>
                 </a:tc>
@@ -11399,7 +11727,7 @@
                         <a:buNone/>
                       </a:pPr>
                       <a:r>
-                        <a:rPr lang="en-US" sz="1300" b="1" dirty="0">
+                        <a:rPr lang="en-US" sz="1200" dirty="0">
                           <a:solidFill>
                             <a:srgbClr val="000000"/>
                           </a:solidFill>
@@ -11407,9 +11735,9 @@
                           <a:ea typeface="Calibri" pitchFamily="34" charset="-122"/>
                           <a:cs typeface="Calibri" pitchFamily="34" charset="-120"/>
                         </a:rPr>
-                        <a:t>0.925</a:t>
+                        <a:t>QLoRA (Unsloth)</a:t>
                       </a:r>
-                      <a:endParaRPr lang="en-US" sz="1300" dirty="0">
+                      <a:endParaRPr lang="en-US" sz="1200" dirty="0">
                         <a:latin typeface="Calibri" charset="0"/>
                         <a:ea typeface="Calibri" charset="0"/>
                         <a:cs typeface="Calibri" charset="0"/>
@@ -11454,7 +11782,7 @@
                       <a:tailEnd type="none" w="med" len="med"/>
                     </a:lnB>
                     <a:solidFill>
-                      <a:srgbClr val="E2EFDA"/>
+                      <a:srgbClr val="FFFFFF"/>
                     </a:solidFill>
                   </a:tcPr>
                 </a:tc>
@@ -11467,7 +11795,7 @@
                         <a:buNone/>
                       </a:pPr>
                       <a:r>
-                        <a:rPr lang="en-US" sz="1300" dirty="0">
+                        <a:rPr lang="en-US" sz="1200" dirty="0">
                           <a:solidFill>
                             <a:srgbClr val="000000"/>
                           </a:solidFill>
@@ -11475,9 +11803,9 @@
                           <a:ea typeface="Calibri" pitchFamily="34" charset="-122"/>
                           <a:cs typeface="Calibri" pitchFamily="34" charset="-120"/>
                         </a:rPr>
-                        <a:t>5.07</a:t>
+                        <a:t>0.788</a:t>
                       </a:r>
-                      <a:endParaRPr lang="en-US" sz="1300" dirty="0">
+                      <a:endParaRPr lang="en-US" sz="1200" dirty="0">
                         <a:latin typeface="Calibri" charset="0"/>
                         <a:ea typeface="Calibri" charset="0"/>
                         <a:cs typeface="Calibri" charset="0"/>
@@ -11522,7 +11850,211 @@
                       <a:tailEnd type="none" w="med" len="med"/>
                     </a:lnB>
                     <a:solidFill>
-                      <a:srgbClr val="E2EFDA"/>
+                      <a:srgbClr val="FFFFFF"/>
+                    </a:solidFill>
+                  </a:tcPr>
+                </a:tc>
+                <a:tc>
+                  <a:txBody>
+                    <a:bodyPr/>
+                    <a:lstStyle/>
+                    <a:p>
+                      <a:pPr algn="ctr" indent="0" marL="0">
+                        <a:buNone/>
+                      </a:pPr>
+                      <a:r>
+                        <a:rPr lang="en-US" sz="1200" dirty="0">
+                          <a:solidFill>
+                            <a:srgbClr val="C0392B"/>
+                          </a:solidFill>
+                          <a:latin typeface="Calibri" pitchFamily="34" charset="0"/>
+                          <a:ea typeface="Calibri" pitchFamily="34" charset="-122"/>
+                          <a:cs typeface="Calibri" pitchFamily="34" charset="-120"/>
+                        </a:rPr>
+                        <a:t>0.740</a:t>
+                      </a:r>
+                      <a:endParaRPr lang="en-US" sz="1200" dirty="0">
+                        <a:latin typeface="Calibri" charset="0"/>
+                        <a:ea typeface="Calibri" charset="0"/>
+                        <a:cs typeface="Calibri" charset="0"/>
+                      </a:endParaRPr>
+                    </a:p>
+                  </a:txBody>
+                  <a:tcPr marL="91440" marR="91440" marT="45720" marB="45720" anchor="ctr">
+                    <a:lnL w="12700" cap="flat" cmpd="sng" algn="ctr">
+                      <a:solidFill>
+                        <a:srgbClr val="D9E1E8"/>
+                      </a:solidFill>
+                      <a:prstDash val="solid"/>
+                      <a:round/>
+                      <a:headEnd type="none" w="med" len="med"/>
+                      <a:tailEnd type="none" w="med" len="med"/>
+                    </a:lnL>
+                    <a:lnR w="12700" cap="flat" cmpd="sng" algn="ctr">
+                      <a:solidFill>
+                        <a:srgbClr val="D9E1E8"/>
+                      </a:solidFill>
+                      <a:prstDash val="solid"/>
+                      <a:round/>
+                      <a:headEnd type="none" w="med" len="med"/>
+                      <a:tailEnd type="none" w="med" len="med"/>
+                    </a:lnR>
+                    <a:lnT w="12700" cap="flat" cmpd="sng" algn="ctr">
+                      <a:solidFill>
+                        <a:srgbClr val="D9E1E8"/>
+                      </a:solidFill>
+                      <a:prstDash val="solid"/>
+                      <a:round/>
+                      <a:headEnd type="none" w="med" len="med"/>
+                      <a:tailEnd type="none" w="med" len="med"/>
+                    </a:lnT>
+                    <a:lnB w="12700" cap="flat" cmpd="sng" algn="ctr">
+                      <a:solidFill>
+                        <a:srgbClr val="D9E1E8"/>
+                      </a:solidFill>
+                      <a:prstDash val="solid"/>
+                      <a:round/>
+                      <a:headEnd type="none" w="med" len="med"/>
+                      <a:tailEnd type="none" w="med" len="med"/>
+                    </a:lnB>
+                    <a:solidFill>
+                      <a:srgbClr val="FFFFFF"/>
+                    </a:solidFill>
+                  </a:tcPr>
+                </a:tc>
+                <a:tc>
+                  <a:txBody>
+                    <a:bodyPr/>
+                    <a:lstStyle/>
+                    <a:p>
+                      <a:pPr algn="ctr" indent="0" marL="0">
+                        <a:buNone/>
+                      </a:pPr>
+                      <a:r>
+                        <a:rPr lang="en-US" sz="1200" dirty="0">
+                          <a:solidFill>
+                            <a:srgbClr val="000000"/>
+                          </a:solidFill>
+                          <a:latin typeface="Calibri" pitchFamily="34" charset="0"/>
+                          <a:ea typeface="Calibri" pitchFamily="34" charset="-122"/>
+                          <a:cs typeface="Calibri" pitchFamily="34" charset="-120"/>
+                        </a:rPr>
+                        <a:t>0.765</a:t>
+                      </a:r>
+                      <a:endParaRPr lang="en-US" sz="1200" dirty="0">
+                        <a:latin typeface="Calibri" charset="0"/>
+                        <a:ea typeface="Calibri" charset="0"/>
+                        <a:cs typeface="Calibri" charset="0"/>
+                      </a:endParaRPr>
+                    </a:p>
+                  </a:txBody>
+                  <a:tcPr marL="91440" marR="91440" marT="45720" marB="45720" anchor="ctr">
+                    <a:lnL w="12700" cap="flat" cmpd="sng" algn="ctr">
+                      <a:solidFill>
+                        <a:srgbClr val="D9E1E8"/>
+                      </a:solidFill>
+                      <a:prstDash val="solid"/>
+                      <a:round/>
+                      <a:headEnd type="none" w="med" len="med"/>
+                      <a:tailEnd type="none" w="med" len="med"/>
+                    </a:lnL>
+                    <a:lnR w="12700" cap="flat" cmpd="sng" algn="ctr">
+                      <a:solidFill>
+                        <a:srgbClr val="D9E1E8"/>
+                      </a:solidFill>
+                      <a:prstDash val="solid"/>
+                      <a:round/>
+                      <a:headEnd type="none" w="med" len="med"/>
+                      <a:tailEnd type="none" w="med" len="med"/>
+                    </a:lnR>
+                    <a:lnT w="12700" cap="flat" cmpd="sng" algn="ctr">
+                      <a:solidFill>
+                        <a:srgbClr val="D9E1E8"/>
+                      </a:solidFill>
+                      <a:prstDash val="solid"/>
+                      <a:round/>
+                      <a:headEnd type="none" w="med" len="med"/>
+                      <a:tailEnd type="none" w="med" len="med"/>
+                    </a:lnT>
+                    <a:lnB w="12700" cap="flat" cmpd="sng" algn="ctr">
+                      <a:solidFill>
+                        <a:srgbClr val="D9E1E8"/>
+                      </a:solidFill>
+                      <a:prstDash val="solid"/>
+                      <a:round/>
+                      <a:headEnd type="none" w="med" len="med"/>
+                      <a:tailEnd type="none" w="med" len="med"/>
+                    </a:lnB>
+                    <a:solidFill>
+                      <a:srgbClr val="FFFFFF"/>
+                    </a:solidFill>
+                  </a:tcPr>
+                </a:tc>
+                <a:tc>
+                  <a:txBody>
+                    <a:bodyPr/>
+                    <a:lstStyle/>
+                    <a:p>
+                      <a:pPr algn="ctr" indent="0" marL="0">
+                        <a:buNone/>
+                      </a:pPr>
+                      <a:r>
+                        <a:rPr lang="en-US" sz="1200" dirty="0">
+                          <a:solidFill>
+                            <a:srgbClr val="000000"/>
+                          </a:solidFill>
+                          <a:latin typeface="Calibri" pitchFamily="34" charset="0"/>
+                          <a:ea typeface="Calibri" pitchFamily="34" charset="-122"/>
+                          <a:cs typeface="Calibri" pitchFamily="34" charset="-120"/>
+                        </a:rPr>
+                        <a:t>9.73</a:t>
+                      </a:r>
+                      <a:endParaRPr lang="en-US" sz="1200" dirty="0">
+                        <a:latin typeface="Calibri" charset="0"/>
+                        <a:ea typeface="Calibri" charset="0"/>
+                        <a:cs typeface="Calibri" charset="0"/>
+                      </a:endParaRPr>
+                    </a:p>
+                  </a:txBody>
+                  <a:tcPr marL="91440" marR="91440" marT="45720" marB="45720" anchor="ctr">
+                    <a:lnL w="12700" cap="flat" cmpd="sng" algn="ctr">
+                      <a:solidFill>
+                        <a:srgbClr val="D9E1E8"/>
+                      </a:solidFill>
+                      <a:prstDash val="solid"/>
+                      <a:round/>
+                      <a:headEnd type="none" w="med" len="med"/>
+                      <a:tailEnd type="none" w="med" len="med"/>
+                    </a:lnL>
+                    <a:lnR w="12700" cap="flat" cmpd="sng" algn="ctr">
+                      <a:solidFill>
+                        <a:srgbClr val="D9E1E8"/>
+                      </a:solidFill>
+                      <a:prstDash val="solid"/>
+                      <a:round/>
+                      <a:headEnd type="none" w="med" len="med"/>
+                      <a:tailEnd type="none" w="med" len="med"/>
+                    </a:lnR>
+                    <a:lnT w="12700" cap="flat" cmpd="sng" algn="ctr">
+                      <a:solidFill>
+                        <a:srgbClr val="D9E1E8"/>
+                      </a:solidFill>
+                      <a:prstDash val="solid"/>
+                      <a:round/>
+                      <a:headEnd type="none" w="med" len="med"/>
+                      <a:tailEnd type="none" w="med" len="med"/>
+                    </a:lnT>
+                    <a:lnB w="12700" cap="flat" cmpd="sng" algn="ctr">
+                      <a:solidFill>
+                        <a:srgbClr val="D9E1E8"/>
+                      </a:solidFill>
+                      <a:prstDash val="solid"/>
+                      <a:round/>
+                      <a:headEnd type="none" w="med" len="med"/>
+                      <a:tailEnd type="none" w="med" len="med"/>
+                    </a:lnB>
+                    <a:solidFill>
+                      <a:srgbClr val="FFFFFF"/>
                     </a:solidFill>
                   </a:tcPr>
                 </a:tc>
@@ -11539,12 +12071,12 @@
         </p:nvSpPr>
         <p:spPr>
           <a:xfrm>
-            <a:off x="640080" y="5349240"/>
-            <a:ext cx="10972800" cy="868680"/>
+            <a:off x="640080" y="5166360"/>
+            <a:ext cx="10972800" cy="1051560"/>
           </a:xfrm>
           <a:prstGeom prst="roundRect">
             <a:avLst>
-              <a:gd name="adj" fmla="val 6316"/>
+              <a:gd name="adj" fmla="val 5217"/>
             </a:avLst>
           </a:prstGeom>
           <a:solidFill>
@@ -11566,8 +12098,8 @@
         </p:nvSpPr>
         <p:spPr>
           <a:xfrm>
-            <a:off x="868680" y="5440680"/>
-            <a:ext cx="10515600" cy="685800"/>
+            <a:off x="868680" y="5257800"/>
+            <a:ext cx="10515600" cy="914400"/>
           </a:xfrm>
           <a:prstGeom prst="rect">
             <a:avLst/>
@@ -11597,7 +12129,7 @@
               <a:buNone/>
             </a:pPr>
             <a:r>
-              <a:rPr lang="en-US" sz="1400" dirty="0">
+              <a:rPr lang="en-US" sz="1300" dirty="0">
                 <a:solidFill>
                   <a:srgbClr val="1B2733"/>
                 </a:solidFill>
@@ -11605,7 +12137,35 @@
                 <a:ea typeface="Calibri" pitchFamily="34" charset="-122"/>
                 <a:cs typeface="Calibri" pitchFamily="34" charset="-120"/>
               </a:rPr>
-              <a:t>Zero-shot görevde çöküyor (Macro-F1 0.094) → QLoRA çarpıcı iyileşme sağlıyor (0.914). Tüm fine-tuned modeller 0/80 ayrıştırma hatası.</a:t>
+              <a:t>Zero-shot çöküyor (0.094) → QLoRA çarpıcı iyileşme (0.914).  </a:t>
+            </a:r>
+            <a:pPr indent="0" marL="0">
+              <a:buNone/>
+            </a:pPr>
+            <a:r>
+              <a:rPr lang="en-US" sz="1300" b="1" dirty="0">
+                <a:solidFill>
+                  <a:srgbClr val="C0392B"/>
+                </a:solidFill>
+                <a:latin typeface="Calibri" pitchFamily="34" charset="0"/>
+                <a:ea typeface="Calibri" pitchFamily="34" charset="-122"/>
+                <a:cs typeface="Calibri" pitchFamily="34" charset="-120"/>
+              </a:rPr>
+              <a:t>Sürpriz: </a:t>
+            </a:r>
+            <a:pPr indent="0" marL="0">
+              <a:buNone/>
+            </a:pPr>
+            <a:r>
+              <a:rPr lang="en-US" sz="1300" dirty="0">
+                <a:solidFill>
+                  <a:srgbClr val="1B2733"/>
+                </a:solidFill>
+                <a:latin typeface="Calibri" pitchFamily="34" charset="0"/>
+                <a:ea typeface="Calibri" pitchFamily="34" charset="-122"/>
+                <a:cs typeface="Calibri" pitchFamily="34" charset="-120"/>
+              </a:rPr>
+              <a:t>en büyük model Gemma-4 (5B) en küçük modellerin gerisinde — küçük veride aşırı uydurma. Tüm fine-tuned modeller 0/80 parse hatası.</a:t>
             </a:r>
             <a:endParaRPr lang="en-US" sz="1400" dirty="0"/>
           </a:p>
@@ -11989,8 +12549,8 @@
         </p:nvSpPr>
         <p:spPr>
           <a:xfrm>
-            <a:off x="8732520" y="2377440"/>
-            <a:ext cx="2697480" cy="3200400"/>
+            <a:off x="8732520" y="2331720"/>
+            <a:ext cx="2697480" cy="3291840"/>
           </a:xfrm>
           <a:prstGeom prst="rect">
             <a:avLst/>
@@ -12004,13 +12564,13 @@
           <a:p>
             <a:pPr marL="152400" indent="-152400">
               <a:spcAft>
-                <a:spcPts val="1200"/>
+                <a:spcPts val="1000"/>
               </a:spcAft>
               <a:buSzPct val="100000"/>
               <a:buChar char="•"/>
             </a:pPr>
             <a:r>
-              <a:rPr lang="en-US" sz="1250" dirty="0">
+              <a:rPr lang="en-US" sz="1200" dirty="0">
                 <a:solidFill>
                   <a:srgbClr val="FFFFFF"/>
                 </a:solidFill>
@@ -12018,20 +12578,20 @@
                 <a:ea typeface="Calibri" pitchFamily="34" charset="-122"/>
                 <a:cs typeface="Calibri" pitchFamily="34" charset="-120"/>
               </a:rPr>
-              <a:t>SmolLM2 azınlık sınıflarda çöküyor (Kayıp 0.38, Bağış 0.42).</a:t>
+              <a:t>TinyLlama &amp; Qwen tüm sınıflarda güçlü.</a:t>
             </a:r>
-            <a:endParaRPr lang="en-US" sz="1250" dirty="0"/>
+            <a:endParaRPr lang="en-US" sz="1200" dirty="0"/>
           </a:p>
           <a:p>
             <a:pPr marL="152400" indent="-152400">
               <a:spcAft>
-                <a:spcPts val="1200"/>
+                <a:spcPts val="1000"/>
               </a:spcAft>
               <a:buSzPct val="100000"/>
               <a:buChar char="•"/>
             </a:pPr>
             <a:r>
-              <a:rPr lang="en-US" sz="1250" dirty="0">
+              <a:rPr lang="en-US" sz="1200" dirty="0">
                 <a:solidFill>
                   <a:srgbClr val="FFFFFF"/>
                 </a:solidFill>
@@ -12039,17 +12599,20 @@
                 <a:ea typeface="Calibri" pitchFamily="34" charset="-122"/>
                 <a:cs typeface="Calibri" pitchFamily="34" charset="-120"/>
               </a:rPr>
-              <a:t>TinyLlama &amp; Qwen azınlık sınıfları çözüyor.</a:t>
+              <a:t>SmolLM2 azınlık sınıflarda çöküyor.</a:t>
             </a:r>
-            <a:endParaRPr lang="en-US" sz="1250" dirty="0"/>
+            <a:endParaRPr lang="en-US" sz="1200" dirty="0"/>
           </a:p>
           <a:p>
             <a:pPr marL="152400" indent="-152400">
+              <a:spcAft>
+                <a:spcPts val="1000"/>
+              </a:spcAft>
               <a:buSzPct val="100000"/>
               <a:buChar char="•"/>
             </a:pPr>
             <a:r>
-              <a:rPr lang="en-US" sz="1250" b="1" dirty="0">
+              <a:rPr lang="en-US" sz="1200" dirty="0">
                 <a:solidFill>
                   <a:srgbClr val="FFD9B3"/>
                 </a:solidFill>
@@ -12057,9 +12620,27 @@
                 <a:ea typeface="Calibri" pitchFamily="34" charset="-122"/>
                 <a:cs typeface="Calibri" pitchFamily="34" charset="-120"/>
               </a:rPr>
-              <a:t>Bağış her modelde en zayıf — Yardım ile örtüşme.</a:t>
+              <a:t>Gemma-4 Kayıp'ta zayıf (recall 0.30) — overfit etkisi.</a:t>
             </a:r>
-            <a:endParaRPr lang="en-US" sz="1250" dirty="0"/>
+            <a:endParaRPr lang="en-US" sz="1200" dirty="0"/>
+          </a:p>
+          <a:p>
+            <a:pPr marL="152400" indent="-152400">
+              <a:buSzPct val="100000"/>
+              <a:buChar char="•"/>
+            </a:pPr>
+            <a:r>
+              <a:rPr lang="en-US" sz="1200" b="1" dirty="0">
+                <a:solidFill>
+                  <a:srgbClr val="FFD9B3"/>
+                </a:solidFill>
+                <a:latin typeface="Calibri" pitchFamily="34" charset="0"/>
+                <a:ea typeface="Calibri" pitchFamily="34" charset="-122"/>
+                <a:cs typeface="Calibri" pitchFamily="34" charset="-120"/>
+              </a:rPr>
+              <a:t>Bağış 3 modelde en zayıf — Yardım ile örtüşme.</a:t>
+            </a:r>
+            <a:endParaRPr lang="en-US" sz="1200" dirty="0"/>
           </a:p>
         </p:txBody>
       </p:sp>
@@ -12408,20 +12989,20 @@
                 <a:ea typeface="Calibri" pitchFamily="34" charset="-122"/>
                 <a:cs typeface="Calibri" pitchFamily="34" charset="-120"/>
               </a:rPr>
-              <a:t>Büyük sıçrama, sonra doygunluk</a:t>
+              <a:t>Bigger ≠ better (küçük veride)</a:t>
             </a:r>
             <a:endParaRPr lang="en-US" sz="1700" dirty="0"/>
           </a:p>
           <a:p>
             <a:pPr marL="177800" indent="-177800">
               <a:spcAft>
-                <a:spcPts val="800"/>
+                <a:spcPts val="600"/>
               </a:spcAft>
               <a:buSzPct val="100000"/>
               <a:buChar char="•"/>
             </a:pPr>
             <a:r>
-              <a:rPr lang="en-US" sz="1400" dirty="0">
+              <a:rPr lang="en-US" sz="1300" dirty="0">
                 <a:solidFill>
                   <a:srgbClr val="1B2733"/>
                 </a:solidFill>
@@ -12429,20 +13010,20 @@
                 <a:ea typeface="Calibri" pitchFamily="34" charset="-122"/>
                 <a:cs typeface="Calibri" pitchFamily="34" charset="-120"/>
               </a:rPr>
-              <a:t>360M → 1.1B: +0.32 Macro-F1 (büyük)</a:t>
+              <a:t>360M → 1.1B: +0.32 (büyük sıçrama)</a:t>
             </a:r>
             <a:endParaRPr lang="en-US" sz="1700" dirty="0"/>
           </a:p>
           <a:p>
             <a:pPr marL="177800" indent="-177800">
               <a:spcAft>
-                <a:spcPts val="800"/>
+                <a:spcPts val="600"/>
               </a:spcAft>
               <a:buSzPct val="100000"/>
               <a:buChar char="•"/>
             </a:pPr>
             <a:r>
-              <a:rPr lang="en-US" sz="1400" dirty="0">
+              <a:rPr lang="en-US" sz="1300" dirty="0">
                 <a:solidFill>
                   <a:srgbClr val="1B2733"/>
                 </a:solidFill>
@@ -12450,20 +13031,37 @@
                 <a:ea typeface="Calibri" pitchFamily="34" charset="-122"/>
                 <a:cs typeface="Calibri" pitchFamily="34" charset="-120"/>
               </a:rPr>
-              <a:t>1.1B → 1.5B: +0.006 (marjinal)</a:t>
+              <a:t>1.1B → 1.5B: +0.006 (doygunluk)</a:t>
             </a:r>
             <a:endParaRPr lang="en-US" sz="1700" dirty="0"/>
           </a:p>
           <a:p>
             <a:pPr marL="177800" indent="-177800">
               <a:spcAft>
-                <a:spcPts val="1600"/>
+                <a:spcPts val="1400"/>
               </a:spcAft>
               <a:buSzPct val="100000"/>
               <a:buChar char="•"/>
             </a:pPr>
             <a:r>
-              <a:rPr lang="en-US" sz="1400" b="1" dirty="0">
+              <a:rPr lang="en-US" sz="1300" b="1" dirty="0">
+                <a:solidFill>
+                  <a:srgbClr val="C0392B"/>
+                </a:solidFill>
+                <a:latin typeface="Calibri" pitchFamily="34" charset="0"/>
+                <a:ea typeface="Calibri" pitchFamily="34" charset="-122"/>
+                <a:cs typeface="Calibri" pitchFamily="34" charset="-120"/>
+              </a:rPr>
+              <a:t>1.5B → 5B: −0.17 (Gemma-4 aşırı uydurma!)</a:t>
+            </a:r>
+            <a:endParaRPr lang="en-US" sz="1700" dirty="0"/>
+          </a:p>
+          <a:p>
+            <a:pPr indent="0" marL="0">
+              <a:buNone/>
+            </a:pPr>
+            <a:r>
+              <a:rPr lang="en-US" sz="1300" b="1" dirty="0">
                 <a:solidFill>
                   <a:srgbClr val="2A9D8F"/>
                 </a:solidFill>
@@ -12471,30 +13069,13 @@
                 <a:ea typeface="Calibri" pitchFamily="34" charset="-122"/>
                 <a:cs typeface="Calibri" pitchFamily="34" charset="-120"/>
               </a:rPr>
-              <a:t>≈1B parametrede getiri doygunlaşıyor.</a:t>
-            </a:r>
-            <a:endParaRPr lang="en-US" sz="1700" dirty="0"/>
-          </a:p>
-          <a:p>
-            <a:pPr indent="0" marL="0">
-              <a:buNone/>
-            </a:pPr>
-            <a:r>
-              <a:rPr lang="en-US" sz="1400" b="1" dirty="0">
-                <a:solidFill>
-                  <a:srgbClr val="C96A28"/>
-                </a:solidFill>
-                <a:latin typeface="Calibri" pitchFamily="34" charset="0"/>
-                <a:ea typeface="Calibri" pitchFamily="34" charset="-122"/>
-                <a:cs typeface="Calibri" pitchFamily="34" charset="-120"/>
-              </a:rPr>
-              <a:t>Verimlilik:  </a:t>
+              <a:t>Sweet spot: </a:t>
             </a:r>
             <a:pPr indent="0" marL="0">
               <a:buNone/>
             </a:pPr>
             <a:r>
-              <a:rPr lang="en-US" sz="1400" dirty="0">
+              <a:rPr lang="en-US" sz="1300" dirty="0">
                 <a:solidFill>
                   <a:srgbClr val="1B2733"/>
                 </a:solidFill>
@@ -12502,7 +13083,7 @@
                 <a:ea typeface="Calibri" pitchFamily="34" charset="-122"/>
                 <a:cs typeface="Calibri" pitchFamily="34" charset="-120"/>
               </a:rPr>
-              <a:t>TinyLlama, Qwen'e neredeyse eşit skoru %35 daha az GPU ile (3.29 vs 5.07 GB) veriyor.</a:t>
+              <a:t>1–1.5B. TinyLlama, Qwen'e ~eşit skoru %35 daha az GPU ile veriyor (3.29 vs 5.07 GB).</a:t>
             </a:r>
             <a:endParaRPr lang="en-US" sz="1700" dirty="0"/>
           </a:p>

</xml_diff>